<commit_message>
Update pitch deck and memo to reflect v0.2 shipped scope
Roadmap sections in both files still listed devis, UBL 2.1 e-invoicing,
and the accountant multi-client dashboard as in-progress/next -- all
three shipped in Sprint 6/9. Corrected to show v0.2 as shipped, replaced
the stale e-invoicing line with what's actually still blocked (DGI/xHub
sandbox + Barid eSign access, not engineering work), and added a bullet
to each of the memo's three language sections covering the new
capabilities. Also refreshed the deck's dashboard screenshots to current
ones.

Co-Authored-By: Claude Sonnet 5 <noreply@anthropic.com>
</commit_message>
<xml_diff>
--- a/pitch/Moqawil-Pitch-Deck.pptx
+++ b/pitch/Moqawil-Pitch-Deck.pptx
@@ -4367,7 +4367,7 @@
                 </a:solidFill>
                 <a:latin typeface="Calibri"/>
               </a:rPr>
-              <a:t>• v0.1 (shipped): compliant invoicing, live 80K cap tracker, annual threshold alerts, quarterly declaration generator, bilingual FR/AR RTL UI, one-command Docker self-host.</a:t>
+              <a:t>• v0.2 (shipped): compliant invoicing, live 80K cap tracker, annual threshold alerts, quarterly declaration generator, devis with one-click invoice conversion, DGI-ready UBL 2.1 e-invoicing export, accountant multi-client read-only dashboard, bilingual FR/AR RTL UI (real content translation, not just layout), one-command Docker self-host.</a:t>
             </a:r>
           </a:p>
         </p:txBody>
@@ -4406,7 +4406,7 @@
                 </a:solidFill>
                 <a:latin typeface="Calibri"/>
               </a:rPr>
-              <a:t>• In progress: DGI e-invoicing readiness — UBL 2.1 XML export per invoice.</a:t>
+              <a:t>• Blocked on external access, not engineering work: full DGI/xHub e-invoicing clearance submission and Barid eSign signing integration both require sandbox/account access from the tax authority.</a:t>
             </a:r>
           </a:p>
           <a:p>
@@ -4422,7 +4422,7 @@
                 </a:solidFill>
                 <a:latin typeface="Calibri"/>
               </a:rPr>
-              <a:t>• Next: accountant multi-client dashboard, quote (devis) management, mobile PWA.</a:t>
+              <a:t>• Next: mobile PWA, public launch.</a:t>
             </a:r>
           </a:p>
           <a:p>
@@ -4438,7 +4438,7 @@
                 </a:solidFill>
                 <a:latin typeface="Calibri"/>
               </a:rPr>
-              <a:t>• Distribution: r/Maroc, r/MoroccanDevs, "Auto-entrepreneurs Maroc" FB group (~90K members), chartered-accountant endorsements, Show HN.</a:t>
+              <a:t>• Distribution: r/Maroc, r/MoroccanDevs, “Auto-entrepreneurs Maroc” FB group (~90K members), chartered-accountant endorsements, Show HN.</a:t>
             </a:r>
           </a:p>
         </p:txBody>
@@ -7733,7 +7733,7 @@
           <p:nvPr/>
         </p:nvPicPr>
         <p:blipFill>
-          <a:blip r:embed="rId2"/>
+          <a:blip r:embed="rId4"/>
           <a:stretch>
             <a:fillRect/>
           </a:stretch>
@@ -7801,7 +7801,7 @@
           <p:nvPr/>
         </p:nvPicPr>
         <p:blipFill>
-          <a:blip r:embed="rId3"/>
+          <a:blip r:embed="rId5"/>
           <a:stretch>
             <a:fillRect/>
           </a:stretch>

</xml_diff>

<commit_message>
Refresh pitch deck and memo for Sprint 11 shipped work + Sprint 12 plan
Business Model and Roadmap sections (deck slides 11+13, memo FR/EN)
now call out Sprint 11's SaaS-readiness hardening as shipped (IDOR
re-audit, rate limiting, health check, automated backups, landing
page) and replace the stale "Next: mobile PWA, public launch" line
with the actual Sprint 12 plan.

Edited via python-pptx/python-docx; layout not visually verified (no
Office/LibreOffice on this machine) — structural validity confirmed
only. Worth a visual check before presenting.

Co-Authored-By: Claude Sonnet 5 <noreply@anthropic.com>
</commit_message>
<xml_diff>
--- a/pitch/Moqawil-Pitch-Deck.pptx
+++ b/pitch/Moqawil-Pitch-Deck.pptx
@@ -3875,7 +3875,7 @@
                 </a:solidFill>
                 <a:latin typeface="Calibri"/>
               </a:rPr>
-              <a:t>• Cloud managé (post-lancement) : hébergement clé-en-main, sauvegardes, support — payant, optionnel, jamais requis pour utiliser le produit.</a:t>
+              <a:t>• Cloud managé (post-lancement) : hébergement clé-en-main, sauvegardes, support — payant, optionnel, jamais requis pour utiliser le produit. Infrastructure prête (Sprint 11) ; ouverture après revue légale et audit sécurité.</a:t>
             </a:r>
           </a:p>
           <a:p>
@@ -4367,7 +4367,7 @@
                 </a:solidFill>
                 <a:latin typeface="Calibri"/>
               </a:rPr>
-              <a:t>• v0.2 (shipped): compliant invoicing, live 80K cap tracker, annual threshold alerts, quarterly declaration generator, devis with one-click invoice conversion, DGI-ready UBL 2.1 e-invoicing export, accountant multi-client read-only dashboard, bilingual FR/AR RTL UI (real content translation, not just layout), one-command Docker self-host.</a:t>
+              <a:t>• v0.2 (shipped): compliant invoicing, live 80K cap tracker, annual threshold alerts, quarterly declaration generator, devis with one-click invoice conversion, DGI-ready UBL 2.1 e-invoicing export, accountant multi-client read-only dashboard, bilingual FR/AR RTL UI (real content translation, not just layout), one-command Docker self-host. Since v0.2: SaaS-readiness hardening — full IDOR re-audit, sign-in rate limiting, a health-check endpoint, automated backups, and a public FR/AR landing page.</a:t>
             </a:r>
           </a:p>
         </p:txBody>
@@ -4422,7 +4422,7 @@
                 </a:solidFill>
                 <a:latin typeface="Calibri"/>
               </a:rPr>
-              <a:t>• Next: mobile PWA, public launch.</a:t>
+              <a:t>• Next (Sprint 12, planned): Terms of Service, Privacy Policy, CNDP data-controller registration, a third-party security audit, and real infra provisioning — owner-side steps before a public hosted launch. Self-host works today regardless.</a:t>
             </a:r>
           </a:p>
           <a:p>

</xml_diff>

<commit_message>
Rework pitch deck with real preprod screenshots and live-demo framing
Swaps the 6 empty-state mockups on the product-tour slides for real frames
pulled from the just-recorded preprod walkthrough (populated cap states in
both FR and AR RTL, the actual blocking dialog, real declarations). Updates
the roadmap to reflect Sprint 12 and Sprint 13 as shipped rather than
planned, and adds the live preprod.moqawiil.com demo link across the title,
model, ask, and closing slides plus every slide footer.

Co-Authored-By: Claude Sonnet 5 <noreply@anthropic.com>
</commit_message>
<xml_diff>
--- a/pitch/Moqawil-Pitch-Deck.pptx
+++ b/pitch/Moqawil-Pitch-Deck.pptx
@@ -3280,7 +3280,7 @@
                 </a:solidFill>
                 <a:latin typeface="Calibri"/>
               </a:rPr>
-              <a:t>Open-source · AGPL-3.0 · FR / دارجة / EN</a:t>
+              <a:t>Open-source · AGPL-3.0 · FR / دارجة / EN · Démo live : preprod.moqawiil.com</a:t>
             </a:r>
           </a:p>
         </p:txBody>
@@ -3664,7 +3664,7 @@
                 </a:solidFill>
                 <a:latin typeface="Calibri"/>
               </a:rPr>
-              <a:t>Moqawil — moqawil.ma (à venir) · github.com/moqawil/moqawil</a:t>
+              <a:t>Moqawil — Démo live : preprod.moqawiil.com · github.com/moqawil/moqawil</a:t>
             </a:r>
           </a:p>
         </p:txBody>
@@ -3875,7 +3875,7 @@
                 </a:solidFill>
                 <a:latin typeface="Calibri"/>
               </a:rPr>
-              <a:t>• Cloud managé (post-lancement) : hébergement clé-en-main, sauvegardes, support — payant, optionnel, jamais requis pour utiliser le produit. Infrastructure prête (Sprint 11) ; ouverture après revue légale et audit sécurité.</a:t>
+              <a:t>• Cloud managé (post-lancement) : hébergement clé-en-main, sauvegardes, support — payant, optionnel, jamais requis pour utiliser le produit. Infrastructure prête et déployée en préproduction — démo live sur preprod.moqawiil.com (Sprint 13) ; ouverture publique après revue légale et audit sécurité.</a:t>
             </a:r>
           </a:p>
           <a:p>
@@ -3926,7 +3926,7 @@
                 </a:solidFill>
                 <a:latin typeface="Calibri"/>
               </a:rPr>
-              <a:t>Moqawil — moqawil.ma (à venir) · github.com/moqawil/moqawil</a:t>
+              <a:t>Moqawil — Démo live : preprod.moqawiil.com · github.com/moqawil/moqawil</a:t>
             </a:r>
           </a:p>
         </p:txBody>
@@ -4188,7 +4188,7 @@
                 </a:solidFill>
                 <a:latin typeface="Calibri"/>
               </a:rPr>
-              <a:t>Moqawil — moqawil.ma (à venir) · github.com/moqawil/moqawil</a:t>
+              <a:t>Moqawil — Démo live : preprod.moqawiil.com · github.com/moqawil/moqawil</a:t>
             </a:r>
           </a:p>
         </p:txBody>
@@ -4422,7 +4422,7 @@
                 </a:solidFill>
                 <a:latin typeface="Calibri"/>
               </a:rPr>
-              <a:t>• Sprint 12 — launch readiness (shipped 2026-08-12): ToS/Privacy Policy drafts, CNDP data-controller registration checklist, pentest scope doc + security posture summary, full deployment runbook, 3 bilingual SEO blog posts live. What remains is owner-only, not engineering: sign ToS/Privacy with a lawyer, file the CNDP registration, hire a pentest vendor, buy a VPS + domain and deploy, and decide on the 5 drafted announcement posts. Self-host works today regardless.</a:t>
+              <a:t>• Sprint 12 — launch readiness (shipped 2026-08-12): ToS/Privacy Policy drafts, CNDP data-controller registration checklist, pentest scope doc + security posture summary, full deployment runbook, 3 bilingual SEO blog posts live. What remains is owner-only, not engineering: sign ToS/Privacy with a lawyer, file the CNDP registration, hire a pentest vendor, and decide on the 5 drafted announcement posts. Self-host works today regardless.</a:t>
             </a:r>
           </a:p>
           <a:p>
@@ -4438,6 +4438,22 @@
                 </a:solidFill>
                 <a:latin typeface="Calibri"/>
               </a:rPr>
+              <a:t>• Sprint 13 (shipped): CI/CD pipeline to a live preprod deploy on a real VPS + domain — try it yourself at preprod.moqawiil.com.</a:t>
+            </a:r>
+          </a:p>
+          <a:p>
+            <a:pPr algn="l">
+              <a:spcAft>
+                <a:spcPts val="1400"/>
+              </a:spcAft>
+            </a:pPr>
+            <a:r>
+              <a:rPr sz="1700">
+                <a:solidFill>
+                  <a:srgbClr val="1A1A1A"/>
+                </a:solidFill>
+                <a:latin typeface="Calibri"/>
+              </a:rPr>
               <a:t>• Distribution: r/Maroc, r/MoroccanDevs, “Auto-entrepreneurs Maroc” FB group (~90K members), chartered-accountant endorsements, Show HN.</a:t>
             </a:r>
           </a:p>
@@ -4473,7 +4489,7 @@
                 </a:solidFill>
                 <a:latin typeface="Calibri"/>
               </a:rPr>
-              <a:t>Moqawil — moqawil.ma (à venir) · github.com/moqawil/moqawil</a:t>
+              <a:t>Moqawil — Démo live : preprod.moqawiil.com · github.com/moqawil/moqawil</a:t>
             </a:r>
           </a:p>
         </p:txBody>
@@ -4588,7 +4604,7 @@
                   <a:srgbClr val="FFFFFF"/>
                 </a:solidFill>
               </a:rPr>
-              <a:t>[FR]  Utilise Moqawil si tu factures en freelance — c'est fait pour toi.</a:t>
+              <a:t>[FR]  Utilise Moqawil si tu factures en freelance — essaie la démo live sur preprod.moqawiil.com.</a:t>
             </a:r>
           </a:p>
         </p:txBody>
@@ -4731,7 +4747,7 @@
                 </a:solidFill>
                 <a:latin typeface="Calibri"/>
               </a:rPr>
-              <a:t>Moqawil — github.com/moqawil/moqawil</a:t>
+              <a:t>Moqawil — preprod.moqawiil.com · github.com/moqawil/moqawil</a:t>
             </a:r>
           </a:p>
         </p:txBody>
@@ -4862,7 +4878,7 @@
                 </a:solidFill>
                 <a:latin typeface="Calibri"/>
               </a:rPr>
-              <a:t>github.com/moqawil/moqawil  ·  AGPL-3.0  ·  Built for the ~400,000 Moroccans who deserve better tools.</a:t>
+              <a:t>github.com/moqawil/moqawil  ·  preprod.moqawiil.com  ·  AGPL-3.0  ·  Built for the ~400,000 Moroccans who deserve better tools.</a:t>
             </a:r>
           </a:p>
         </p:txBody>
@@ -5175,7 +5191,7 @@
                 </a:solidFill>
                 <a:latin typeface="Calibri"/>
               </a:rPr>
-              <a:t>Moqawil — moqawil.ma (à venir) · github.com/moqawil/moqawil</a:t>
+              <a:t>Moqawil — Démo live : preprod.moqawiil.com · github.com/moqawil/moqawil</a:t>
             </a:r>
           </a:p>
         </p:txBody>
@@ -5488,7 +5504,7 @@
                 </a:solidFill>
                 <a:latin typeface="Calibri"/>
               </a:rPr>
-              <a:t>Moqawil — moqawil.ma (à venir) · github.com/moqawil/moqawil</a:t>
+              <a:t>Moqawil — Démo live : preprod.moqawiil.com · github.com/moqawil/moqawil</a:t>
             </a:r>
           </a:p>
         </p:txBody>
@@ -5923,7 +5939,7 @@
                 </a:solidFill>
                 <a:latin typeface="Calibri"/>
               </a:rPr>
-              <a:t>Moqawil — moqawil.ma (à venir) · github.com/moqawil/moqawil</a:t>
+              <a:t>Moqawil — Démo live : preprod.moqawiil.com · github.com/moqawil/moqawil</a:t>
             </a:r>
           </a:p>
         </p:txBody>
@@ -6367,7 +6383,7 @@
                 </a:solidFill>
                 <a:latin typeface="Calibri"/>
               </a:rPr>
-              <a:t>Moqawil — moqawil.ma (à venir) · github.com/moqawil/moqawil</a:t>
+              <a:t>Moqawil — Démo live : preprod.moqawiil.com · github.com/moqawil/moqawil</a:t>
             </a:r>
           </a:p>
         </p:txBody>
@@ -7579,7 +7595,7 @@
                 </a:solidFill>
                 <a:latin typeface="Calibri"/>
               </a:rPr>
-              <a:t>Moqawil — moqawil.ma (à venir) · github.com/moqawil/moqawil</a:t>
+              <a:t>Moqawil — Démo live : preprod.moqawiil.com · github.com/moqawil/moqawil</a:t>
             </a:r>
           </a:p>
         </p:txBody>
@@ -7724,30 +7740,6 @@
           </a:p>
         </p:txBody>
       </p:sp>
-      <p:pic>
-        <p:nvPicPr>
-          <p:cNvPr id="5" name="Picture 4" descr="04-dashboard.png"/>
-          <p:cNvPicPr>
-            <a:picLocks noChangeAspect="1"/>
-          </p:cNvPicPr>
-          <p:nvPr/>
-        </p:nvPicPr>
-        <p:blipFill>
-          <a:blip r:embed="rId4"/>
-          <a:stretch>
-            <a:fillRect/>
-          </a:stretch>
-        </p:blipFill>
-        <p:spPr>
-          <a:xfrm>
-            <a:off x="548640" y="1554480"/>
-            <a:ext cx="5120640" cy="2880360"/>
-          </a:xfrm>
-          <a:prstGeom prst="rect">
-            <a:avLst/>
-          </a:prstGeom>
-        </p:spPr>
-      </p:pic>
       <p:sp>
         <p:nvSpPr>
           <p:cNvPr id="6" name="Rectangle 5"/>
@@ -7792,30 +7784,6 @@
           </a:p>
         </p:txBody>
       </p:sp>
-      <p:pic>
-        <p:nvPicPr>
-          <p:cNvPr id="7" name="Picture 6" descr="05-dashboard-arabic-rtl.png"/>
-          <p:cNvPicPr>
-            <a:picLocks noChangeAspect="1"/>
-          </p:cNvPicPr>
-          <p:nvPr/>
-        </p:nvPicPr>
-        <p:blipFill>
-          <a:blip r:embed="rId5"/>
-          <a:stretch>
-            <a:fillRect/>
-          </a:stretch>
-        </p:blipFill>
-        <p:spPr>
-          <a:xfrm>
-            <a:off x="6035040" y="1554480"/>
-            <a:ext cx="5120640" cy="2880360"/>
-          </a:xfrm>
-          <a:prstGeom prst="rect">
-            <a:avLst/>
-          </a:prstGeom>
-        </p:spPr>
-      </p:pic>
       <p:sp>
         <p:nvSpPr>
           <p:cNvPr id="8" name="Rectangle 7"/>
@@ -7925,7 +7893,7 @@
                 </a:solidFill>
                 <a:latin typeface="Calibri"/>
               </a:rPr>
-              <a:t>لوحة القيادة — العربية (RTL)</a:t>
+              <a:t>العملاء — بالعربية (RTL)</a:t>
             </a:r>
           </a:p>
         </p:txBody>
@@ -7960,11 +7928,59 @@
                 </a:solidFill>
                 <a:latin typeface="Calibri"/>
               </a:rPr>
-              <a:t>Moqawil — moqawil.ma (à venir) · github.com/moqawil/moqawil</a:t>
-            </a:r>
-          </a:p>
-        </p:txBody>
-      </p:sp>
+              <a:t>Moqawil — Démo live : preprod.moqawiil.com · github.com/moqawil/moqawil</a:t>
+            </a:r>
+          </a:p>
+        </p:txBody>
+      </p:sp>
+      <p:pic>
+        <p:nvPicPr>
+          <p:cNvPr id="12" name="Picture 11" descr="slide7_left.png"/>
+          <p:cNvPicPr>
+            <a:picLocks noChangeAspect="1"/>
+          </p:cNvPicPr>
+          <p:nvPr/>
+        </p:nvPicPr>
+        <p:blipFill>
+          <a:blip r:embed="rId6"/>
+          <a:stretch>
+            <a:fillRect/>
+          </a:stretch>
+        </p:blipFill>
+        <p:spPr>
+          <a:xfrm>
+            <a:off x="548640" y="1554480"/>
+            <a:ext cx="5120640" cy="2880360"/>
+          </a:xfrm>
+          <a:prstGeom prst="rect">
+            <a:avLst/>
+          </a:prstGeom>
+        </p:spPr>
+      </p:pic>
+      <p:pic>
+        <p:nvPicPr>
+          <p:cNvPr id="13" name="Picture 12" descr="slide7_right.png"/>
+          <p:cNvPicPr>
+            <a:picLocks noChangeAspect="1"/>
+          </p:cNvPicPr>
+          <p:nvPr/>
+        </p:nvPicPr>
+        <p:blipFill>
+          <a:blip r:embed="rId7"/>
+          <a:stretch>
+            <a:fillRect/>
+          </a:stretch>
+        </p:blipFill>
+        <p:spPr>
+          <a:xfrm>
+            <a:off x="6035040" y="1554480"/>
+            <a:ext cx="5120640" cy="2880360"/>
+          </a:xfrm>
+          <a:prstGeom prst="rect">
+            <a:avLst/>
+          </a:prstGeom>
+        </p:spPr>
+      </p:pic>
     </p:spTree>
   </p:cSld>
   <p:clrMapOvr>
@@ -8105,30 +8121,6 @@
           </a:p>
         </p:txBody>
       </p:sp>
-      <p:pic>
-        <p:nvPicPr>
-          <p:cNvPr id="5" name="Picture 4" descr="10-client-detail-cap-badge.png"/>
-          <p:cNvPicPr>
-            <a:picLocks noChangeAspect="1"/>
-          </p:cNvPicPr>
-          <p:nvPr/>
-        </p:nvPicPr>
-        <p:blipFill>
-          <a:blip r:embed="rId2"/>
-          <a:stretch>
-            <a:fillRect/>
-          </a:stretch>
-        </p:blipFill>
-        <p:spPr>
-          <a:xfrm>
-            <a:off x="548640" y="1554480"/>
-            <a:ext cx="5120640" cy="2880360"/>
-          </a:xfrm>
-          <a:prstGeom prst="rect">
-            <a:avLst/>
-          </a:prstGeom>
-        </p:spPr>
-      </p:pic>
       <p:sp>
         <p:nvSpPr>
           <p:cNvPr id="6" name="Rectangle 5"/>
@@ -8173,30 +8165,6 @@
           </a:p>
         </p:txBody>
       </p:sp>
-      <p:pic>
-        <p:nvPicPr>
-          <p:cNvPr id="7" name="Picture 6" descr="21-cap-over-limit-dialog.png"/>
-          <p:cNvPicPr>
-            <a:picLocks noChangeAspect="1"/>
-          </p:cNvPicPr>
-          <p:nvPr/>
-        </p:nvPicPr>
-        <p:blipFill>
-          <a:blip r:embed="rId3"/>
-          <a:stretch>
-            <a:fillRect/>
-          </a:stretch>
-        </p:blipFill>
-        <p:spPr>
-          <a:xfrm>
-            <a:off x="6035040" y="1554480"/>
-            <a:ext cx="5120640" cy="2880360"/>
-          </a:xfrm>
-          <a:prstGeom prst="rect">
-            <a:avLst/>
-          </a:prstGeom>
-        </p:spPr>
-      </p:pic>
       <p:sp>
         <p:nvSpPr>
           <p:cNvPr id="8" name="Rectangle 7"/>
@@ -8271,7 +8239,7 @@
                 </a:solidFill>
                 <a:latin typeface="Calibri"/>
               </a:rPr>
-              <a:t>Fiche client — badge de plafond en temps réel</a:t>
+              <a:t>Liste clients — badge de plafond en temps réel</a:t>
             </a:r>
           </a:p>
         </p:txBody>
@@ -8341,11 +8309,59 @@
                 </a:solidFill>
                 <a:latin typeface="Calibri"/>
               </a:rPr>
-              <a:t>Moqawil — moqawil.ma (à venir) · github.com/moqawil/moqawil</a:t>
-            </a:r>
-          </a:p>
-        </p:txBody>
-      </p:sp>
+              <a:t>Moqawil — Démo live : preprod.moqawiil.com · github.com/moqawil/moqawil</a:t>
+            </a:r>
+          </a:p>
+        </p:txBody>
+      </p:sp>
+      <p:pic>
+        <p:nvPicPr>
+          <p:cNvPr id="12" name="Picture 11" descr="slide8_left.png"/>
+          <p:cNvPicPr>
+            <a:picLocks noChangeAspect="1"/>
+          </p:cNvPicPr>
+          <p:nvPr/>
+        </p:nvPicPr>
+        <p:blipFill>
+          <a:blip r:embed="rId4"/>
+          <a:stretch>
+            <a:fillRect/>
+          </a:stretch>
+        </p:blipFill>
+        <p:spPr>
+          <a:xfrm>
+            <a:off x="548640" y="1554480"/>
+            <a:ext cx="5120640" cy="2880360"/>
+          </a:xfrm>
+          <a:prstGeom prst="rect">
+            <a:avLst/>
+          </a:prstGeom>
+        </p:spPr>
+      </p:pic>
+      <p:pic>
+        <p:nvPicPr>
+          <p:cNvPr id="13" name="Picture 12" descr="slide8_right.png"/>
+          <p:cNvPicPr>
+            <a:picLocks noChangeAspect="1"/>
+          </p:cNvPicPr>
+          <p:nvPr/>
+        </p:nvPicPr>
+        <p:blipFill>
+          <a:blip r:embed="rId5"/>
+          <a:stretch>
+            <a:fillRect/>
+          </a:stretch>
+        </p:blipFill>
+        <p:spPr>
+          <a:xfrm>
+            <a:off x="6035040" y="1554480"/>
+            <a:ext cx="5120640" cy="2880360"/>
+          </a:xfrm>
+          <a:prstGeom prst="rect">
+            <a:avLst/>
+          </a:prstGeom>
+        </p:spPr>
+      </p:pic>
     </p:spTree>
   </p:cSld>
   <p:clrMapOvr>
@@ -8486,30 +8502,6 @@
           </a:p>
         </p:txBody>
       </p:sp>
-      <p:pic>
-        <p:nvPicPr>
-          <p:cNvPr id="5" name="Picture 4" descr="12-invoice-new-filled.png"/>
-          <p:cNvPicPr>
-            <a:picLocks noChangeAspect="1"/>
-          </p:cNvPicPr>
-          <p:nvPr/>
-        </p:nvPicPr>
-        <p:blipFill>
-          <a:blip r:embed="rId2"/>
-          <a:stretch>
-            <a:fillRect/>
-          </a:stretch>
-        </p:blipFill>
-        <p:spPr>
-          <a:xfrm>
-            <a:off x="548640" y="1554480"/>
-            <a:ext cx="5120640" cy="2880360"/>
-          </a:xfrm>
-          <a:prstGeom prst="rect">
-            <a:avLst/>
-          </a:prstGeom>
-        </p:spPr>
-      </p:pic>
       <p:sp>
         <p:nvSpPr>
           <p:cNvPr id="6" name="Rectangle 5"/>
@@ -8554,30 +8546,6 @@
           </a:p>
         </p:txBody>
       </p:sp>
-      <p:pic>
-        <p:nvPicPr>
-          <p:cNvPr id="7" name="Picture 6" descr="19-declarations-generated.png"/>
-          <p:cNvPicPr>
-            <a:picLocks noChangeAspect="1"/>
-          </p:cNvPicPr>
-          <p:nvPr/>
-        </p:nvPicPr>
-        <p:blipFill>
-          <a:blip r:embed="rId3"/>
-          <a:stretch>
-            <a:fillRect/>
-          </a:stretch>
-        </p:blipFill>
-        <p:spPr>
-          <a:xfrm>
-            <a:off x="6035040" y="1554480"/>
-            <a:ext cx="5120640" cy="2880360"/>
-          </a:xfrm>
-          <a:prstGeom prst="rect">
-            <a:avLst/>
-          </a:prstGeom>
-        </p:spPr>
-      </p:pic>
       <p:sp>
         <p:nvSpPr>
           <p:cNvPr id="8" name="Rectangle 7"/>
@@ -8722,11 +8690,59 @@
                 </a:solidFill>
                 <a:latin typeface="Calibri"/>
               </a:rPr>
-              <a:t>Moqawil — moqawil.ma (à venir) · github.com/moqawil/moqawil</a:t>
-            </a:r>
-          </a:p>
-        </p:txBody>
-      </p:sp>
+              <a:t>Moqawil — Démo live : preprod.moqawiil.com · github.com/moqawil/moqawil</a:t>
+            </a:r>
+          </a:p>
+        </p:txBody>
+      </p:sp>
+      <p:pic>
+        <p:nvPicPr>
+          <p:cNvPr id="12" name="Picture 11" descr="slide9_left.png"/>
+          <p:cNvPicPr>
+            <a:picLocks noChangeAspect="1"/>
+          </p:cNvPicPr>
+          <p:nvPr/>
+        </p:nvPicPr>
+        <p:blipFill>
+          <a:blip r:embed="rId4"/>
+          <a:stretch>
+            <a:fillRect/>
+          </a:stretch>
+        </p:blipFill>
+        <p:spPr>
+          <a:xfrm>
+            <a:off x="548640" y="1554480"/>
+            <a:ext cx="5120640" cy="2880360"/>
+          </a:xfrm>
+          <a:prstGeom prst="rect">
+            <a:avLst/>
+          </a:prstGeom>
+        </p:spPr>
+      </p:pic>
+      <p:pic>
+        <p:nvPicPr>
+          <p:cNvPr id="13" name="Picture 12" descr="slide9_right.png"/>
+          <p:cNvPicPr>
+            <a:picLocks noChangeAspect="1"/>
+          </p:cNvPicPr>
+          <p:nvPr/>
+        </p:nvPicPr>
+        <p:blipFill>
+          <a:blip r:embed="rId5"/>
+          <a:stretch>
+            <a:fillRect/>
+          </a:stretch>
+        </p:blipFill>
+        <p:spPr>
+          <a:xfrm>
+            <a:off x="6035040" y="1554480"/>
+            <a:ext cx="5120640" cy="2880360"/>
+          </a:xfrm>
+          <a:prstGeom prst="rect">
+            <a:avLst/>
+          </a:prstGeom>
+        </p:spPr>
+      </p:pic>
     </p:spTree>
   </p:cSld>
   <p:clrMapOvr>

</xml_diff>